<commit_message>
docs: add maintainer documentation and tidy repository
- Add documentation/PROJECT_MAINTENANCE_MANUAL.md plus focused guides
  (ARCHITECTURE, DEVELOPMENT_SETUP, DEPLOYMENT, TESTING) and a
  REPOSITORY_CLEANUP_REPORT, all checked against the source.
- README/CONTRIBUTING: drop the unverified "Tests: Passing" badge, describe
  receipts as issued at finalization, mark realtime optional, replace the
  non-working db:migrate setup step, and target a local DB for npm test.
- Mark outdated docs/ pages as partly superseded.
- CI: run the database-free unit tests and use the Node version from .nvmrc.
- Remove committed Python bytecode and an Office lock file; ignore both.
- Include the updated project presentation.
</commit_message>
<xml_diff>
--- a/artifacts/presentation/ELECTIFY_A_REAL-TIME_ELECTIVE_REGISTRATION_SYSTEM_WITH_TRANSACTIONAL_SEAT_MANAGEMENT_Project_Presentation.pptx
+++ b/artifacts/presentation/ELECTIFY_A_REAL-TIME_ELECTIVE_REGISTRATION_SYSTEM_WITH_TRANSACTIONAL_SEAT_MANAGEMENT_Project_Presentation.pptx
@@ -4631,7 +4631,7 @@
               </a:lnSpc>
             </a:pPr>
             <a:r>
-              <a:rPr sz="3200" b="0" i="0">
+              <a:rPr sz="3200" b="0" i="0" dirty="0">
                 <a:solidFill>
                   <a:srgbClr val="FFFFFF"/>
                 </a:solidFill>
@@ -4686,7 +4686,7 @@
         <p:spPr>
           <a:xfrm>
             <a:off x="548640" y="4617720"/>
-            <a:ext cx="3566160" cy="365760"/>
+            <a:ext cx="3566160" cy="307777"/>
           </a:xfrm>
           <a:prstGeom prst="rect">
             <a:avLst/>
@@ -4701,14 +4701,20 @@
           <a:p>
             <a:pPr algn="l"/>
             <a:r>
-              <a:rPr sz="2000" b="1" i="0">
+              <a:rPr lang="en-US" sz="2000" b="1" dirty="0">
                 <a:solidFill>
                   <a:srgbClr val="FFFFFF"/>
                 </a:solidFill>
                 <a:latin typeface="Calibri"/>
               </a:rPr>
-              <a:t>MATHESHWARAN R</a:t>
-            </a:r>
+              <a:t>DEVANANDA</a:t>
+            </a:r>
+            <a:endParaRPr sz="2000" b="1" i="0" dirty="0">
+              <a:solidFill>
+                <a:srgbClr val="FFFFFF"/>
+              </a:solidFill>
+              <a:latin typeface="Calibri"/>
+            </a:endParaRPr>
           </a:p>
         </p:txBody>
       </p:sp>
@@ -4721,7 +4727,7 @@
         <p:spPr>
           <a:xfrm>
             <a:off x="548640" y="4983480"/>
-            <a:ext cx="3566160" cy="292608"/>
+            <a:ext cx="3566160" cy="230832"/>
           </a:xfrm>
           <a:prstGeom prst="rect">
             <a:avLst/>
@@ -4736,14 +4742,29 @@
           <a:p>
             <a:pPr algn="l"/>
             <a:r>
-              <a:rPr sz="1500" b="0" i="0">
+              <a:rPr sz="1500" b="0" i="0" dirty="0">
                 <a:solidFill>
                   <a:srgbClr val="B9BED3"/>
                 </a:solidFill>
                 <a:latin typeface="Calibri"/>
               </a:rPr>
-              <a:t>Register No. RA2532241010311</a:t>
-            </a:r>
+              <a:t>Register No. RA25322410103</a:t>
+            </a:r>
+            <a:r>
+              <a:rPr lang="en-US" sz="1500" b="0" i="0" dirty="0">
+                <a:solidFill>
+                  <a:srgbClr val="B9BED3"/>
+                </a:solidFill>
+                <a:latin typeface="Calibri"/>
+              </a:rPr>
+              <a:t>32</a:t>
+            </a:r>
+            <a:endParaRPr sz="1500" b="0" i="0" dirty="0">
+              <a:solidFill>
+                <a:srgbClr val="B9BED3"/>
+              </a:solidFill>
+              <a:latin typeface="Calibri"/>
+            </a:endParaRPr>
           </a:p>
         </p:txBody>
       </p:sp>
@@ -4771,7 +4792,7 @@
           <a:p>
             <a:pPr algn="l"/>
             <a:r>
-              <a:rPr sz="1100" b="1" i="0">
+              <a:rPr sz="1100" b="1" i="0" dirty="0">
                 <a:solidFill>
                   <a:srgbClr val="B9BED3"/>
                 </a:solidFill>
@@ -17837,7 +17858,7 @@
         <p:spPr>
           <a:xfrm>
             <a:off x="548640" y="4617720"/>
-            <a:ext cx="3566160" cy="365760"/>
+            <a:ext cx="3566160" cy="307777"/>
           </a:xfrm>
           <a:prstGeom prst="rect">
             <a:avLst/>
@@ -17852,14 +17873,20 @@
           <a:p>
             <a:pPr algn="l"/>
             <a:r>
-              <a:rPr sz="2000" b="1" i="0">
+              <a:rPr lang="en-US" sz="2000" b="1" dirty="0">
                 <a:solidFill>
                   <a:srgbClr val="FFFFFF"/>
                 </a:solidFill>
                 <a:latin typeface="Calibri"/>
               </a:rPr>
-              <a:t>MATHESHWARAN R</a:t>
-            </a:r>
+              <a:t>DEVANANDA</a:t>
+            </a:r>
+            <a:endParaRPr sz="2000" b="1" i="0" dirty="0">
+              <a:solidFill>
+                <a:srgbClr val="FFFFFF"/>
+              </a:solidFill>
+              <a:latin typeface="Calibri"/>
+            </a:endParaRPr>
           </a:p>
         </p:txBody>
       </p:sp>
@@ -17907,7 +17934,7 @@
         <p:spPr>
           <a:xfrm>
             <a:off x="4297680" y="4617720"/>
-            <a:ext cx="4206240" cy="365760"/>
+            <a:ext cx="4206240" cy="307777"/>
           </a:xfrm>
           <a:prstGeom prst="rect">
             <a:avLst/>
@@ -17922,14 +17949,29 @@
           <a:p>
             <a:pPr algn="l"/>
             <a:r>
-              <a:rPr sz="2000" b="1" i="0">
+              <a:rPr sz="2000" b="1" i="0" dirty="0">
                 <a:solidFill>
                   <a:srgbClr val="FFFFFF"/>
                 </a:solidFill>
                 <a:latin typeface="Calibri"/>
               </a:rPr>
-              <a:t>RA2532241010311</a:t>
-            </a:r>
+              <a:t>RA25322410103</a:t>
+            </a:r>
+            <a:r>
+              <a:rPr lang="en-US" sz="2000" b="1" i="0" dirty="0">
+                <a:solidFill>
+                  <a:srgbClr val="FFFFFF"/>
+                </a:solidFill>
+                <a:latin typeface="Calibri"/>
+              </a:rPr>
+              <a:t>32</a:t>
+            </a:r>
+            <a:endParaRPr sz="2000" b="1" i="0" dirty="0">
+              <a:solidFill>
+                <a:srgbClr val="FFFFFF"/>
+              </a:solidFill>
+              <a:latin typeface="Calibri"/>
+            </a:endParaRPr>
           </a:p>
         </p:txBody>
       </p:sp>

</xml_diff>